<commit_message>
Update evidence narrative and registration shape panel with findings from Croesus session
- Revised the evidence narrative to reflect the updated date and key findings from the three-way session with Croesus, emphasizing the type mismatch in application registration.
- Enhanced the RegistrationShapePanel component to clarify the distinction between `spa` and `web` platform registrations, including new findings and implications for GPD Central.
- Added a new document detailing the findings from the three-way session, outlining the current state, open questions, and potential routes for resolution.
</commit_message>
<xml_diff>
--- a/docs/deck/croesus-session-deck-fr.pptx
+++ b/docs/deck/croesus-session-deck-fr.pptx
@@ -515,7 +515,7 @@
           <a:lstStyle/>
           <a:p>
             <a:r>
-              <a:t>Cadrage : il s'agit d'une séance conjointe d'établissement des faits, non d'un rapport de défaut. Le blocage d'accès conditionnel est correct par conception. Il reste une question ouverte et deux demandes qui la referment.</a:t>
+              <a:t>Cadrage : il s'agit d'une séance conjointe d'établissement des faits, non d'un rapport de défaut. Le blocage d'accès conditionnel est correct par conception. La portée se limite à GPD Central — Conseiller est un produit distinct et une évaluation distincte. Le dire d'emblée.</a:t>
             </a:r>
           </a:p>
         </p:txBody>
@@ -585,7 +585,7 @@
           <a:lstStyle/>
           <a:p>
             <a:r>
-              <a:t>Insister d'emblée sur la règle de caviardage. C'est ce qui rend Q7 répondable par un fournisseur soucieux de sécurité.</a:t>
+              <a:t>Insister d'emblée sur la règle de caviardage — c'est ce qui rend Q7 répondable par un fournisseur soucieux de sécurité. Q8 passe en tête car elle peut lever l'ambiguïté en une seule réponse.</a:t>
             </a:r>
           </a:p>
         </p:txBody>
@@ -655,7 +655,7 @@
           <a:lstStyle/>
           <a:p>
             <a:r>
-              <a:t>Le message : chaque branche a un correctif modeste et réversible. Personne n'a besoin d'une refonte, et Desjardins n'a pas à affaiblir son accès conditionnel. Sur la confiance d'appareil — créditer Mathieu Santerre pour la correction : les paramètres de confiance entrante honorent une revendication d'appareil portée par le jeton d'un invité provenant de son locataire d'origine ; ils ne peuvent donc pas transposer l'état d'appareil de Prod dans une connexion native en préproduction.</a:t>
+              <a:t>Le message : chaque voie est modeste et réversible. Personne n'a besoin d'une refonte, et Desjardins n'a pas à affaiblir son accès conditionnel. Sur la confiance d'appareil — créditer Mathieu Santerre pour la correction : les paramètres de confiance entrante honorent une revendication d'appareil portée par le jeton d'un invité provenant de son locataire d'origine ; ils ne peuvent donc pas transposer l'état d'appareil de Prod dans une connexion native en préproduction.</a:t>
             </a:r>
           </a:p>
         </p:txBody>
@@ -725,7 +725,7 @@
           <a:lstStyle/>
           <a:p>
             <a:r>
-              <a:t>Ordre de la démo : se connecter, appeler l'API, montrer le panneau de preuve, puis le bouton de rejeu, puis faire défiler jusqu'au panneau de bifurcation d'inscription et cliquer vers Q7/Q8.</a:t>
+              <a:t>Ordre de la démo : se connecter, appeler l'API, montrer le panneau de preuve, puis le bouton de rejeu, puis faire défiler jusqu'au panneau d'erreur de type d'inscription et cliquer vers Q8/Q7.</a:t>
             </a:r>
           </a:p>
         </p:txBody>
@@ -795,7 +795,7 @@
           <a:lstStyle/>
           <a:p>
             <a:r>
-              <a:t>Conclure en redisant le garde-fou. Il protège les deux parties : aucun relâchement prématuré de politique, aucune refonte prématurée du côté du fournisseur.</a:t>
+              <a:t>Conclure en redisant le garde-fou. Il protège les deux parties : aucun relâchement prématuré de politique, aucune refonte prématurée du côté du fournisseur. L'élément 1 nous appartient et ne dépend de personne.</a:t>
             </a:r>
           </a:p>
         </p:txBody>
@@ -1005,7 +1005,7 @@
           <a:lstStyle/>
           <a:p>
             <a:r>
-              <a:t>Cette diapositive est le résumé exécutif. Si la séance s'arrête après cinq minutes, ce sont ces cinq lignes qui doivent passer.</a:t>
+              <a:t>Cette diapositive est le résumé exécutif. Si la séance s'arrête après cinq minutes, ce sont ces cinq lignes qui doivent passer. Portée : Central seulement.</a:t>
             </a:r>
           </a:p>
         </p:txBody>
@@ -1215,7 +1215,7 @@
           <a:lstStyle/>
           <a:p>
             <a:r>
-              <a:t>C'est la diapositive centrale de l'hypothèse. Exactement une branche est vraie, et chacune appelle une remédiation différente et modeste. Ni l'une ni l'autre n'est une crise.</a:t>
+              <a:t>Diapositive centrale. Aucune des deux explications n'est une crise et chacune appelle une remédiation modeste. Q8 les sépare en une seule réponse.</a:t>
             </a:r>
           </a:p>
         </p:txBody>
@@ -1285,7 +1285,7 @@
           <a:lstStyle/>
           <a:p>
             <a:r>
-              <a:t>Formuler le point techniquement, sans accusation : c'est une règle de la plateforme, pas une opinion. Et le correctif est peu coûteux dans les deux branches.</a:t>
+              <a:t>Formuler le point techniquement, sans accusation : c'est une règle de la plateforme, pas une opinion. Et la première étape du correctif est peu coûteuse.</a:t>
             </a:r>
           </a:p>
         </p:txBody>
@@ -1355,7 +1355,7 @@
           <a:lstStyle/>
           <a:p>
             <a:r>
-              <a:t>Le panneau s'affiche sans connexion : il peut donc être présenté en partage d'écran. Q7, Q8 et la liste complète des questions sont cliquables directement depuis la page. L'interface de la démo est en anglais.</a:t>
+              <a:t>Le panneau s'affiche sans connexion : il peut donc être présenté en partage d'écran. Q8, Q7 et la liste complète des questions sont cliquables directement depuis la page. L'interface de la démo est en anglais.</a:t>
             </a:r>
           </a:p>
         </p:txBody>
@@ -4549,7 +4549,7 @@
                 <a:latin typeface="Segoe UI"/>
               </a:rPr>
               <a:t>SSO GPD Central : ce que la preuve démontre,
-et les deux questions qui règlent le dossier</a:t>
+et les voies qui règlent le dossier</a:t>
             </a:r>
           </a:p>
         </p:txBody>
@@ -4584,7 +4584,7 @@
                 </a:solidFill>
                 <a:latin typeface="Segoe UI"/>
               </a:rPr>
-              <a:t>Inscriptions d'applications Entra ID, accès conditionnel et l'échange du code sur /token côté serveur</a:t>
+              <a:t>Inscriptions d'applications Entra ID, accès conditionnel et l'échange du code sur /token côté serveur  |  Central seulement — pas Conseiller</a:t>
             </a:r>
           </a:p>
         </p:txBody>
@@ -4619,7 +4619,7 @@
                 </a:solidFill>
                 <a:latin typeface="Segoe UI"/>
               </a:rPr>
-              <a:t>3 août 2026</a:t>
+              <a:t>5 août 2026  —  mis à jour après la séance tripartite</a:t>
             </a:r>
           </a:p>
         </p:txBody>
@@ -4651,7 +4651,7 @@
                 <a:latin typeface="Segoe UI"/>
                 <a:hlinkClick r:id="rId2"/>
               </a:rPr>
-              <a:t>▶  Démo en direct — croesus-spa.azurewebsites.net</a:t>
+              <a:t>▶  Constats de la séance et les huit voies</a:t>
             </a:r>
           </a:p>
         </p:txBody>
@@ -4683,7 +4683,7 @@
                 <a:latin typeface="Segoe UI"/>
                 <a:hlinkClick r:id="rId3"/>
               </a:rPr>
-              <a:t>▶  Liste des questions (Q1–Q9) sur GitHub</a:t>
+              <a:t>▶  Liste des questions (Q1–Q14) sur GitHub</a:t>
             </a:r>
           </a:p>
         </p:txBody>
@@ -4715,7 +4715,7 @@
                 <a:latin typeface="Segoe UI"/>
                 <a:hlinkClick r:id="rId4"/>
               </a:rPr>
-              <a:t>▶  Analyse complète — README</a:t>
+              <a:t>▶  Démo en direct — croesus-spa.azurewebsites.net</a:t>
             </a:r>
           </a:p>
         </p:txBody>
@@ -4811,7 +4811,7 @@
                 </a:solidFill>
                 <a:latin typeface="Segoe UI"/>
               </a:rPr>
-              <a:t>Les demandes : Q7 et Q8</a:t>
+              <a:t>Les demandes : Q8 d'abord, puis Q7</a:t>
             </a:r>
           </a:p>
         </p:txBody>
@@ -4978,7 +4978,7 @@
                 </a:solidFill>
                 <a:latin typeface="Segoe UI"/>
               </a:rPr>
-              <a:t>Q7 — une capture /token caviardée</a:t>
+              <a:t>Q8 — inventaire complet des inscriptions</a:t>
             </a:r>
           </a:p>
         </p:txBody>
@@ -5017,7 +5017,7 @@
                 </a:solidFill>
                 <a:latin typeface="Segoe UI"/>
               </a:rPr>
-              <a:t>Pour une transaction réussie et une transaction en échec :</a:t>
+              <a:t>Chaque inscription d'application et principal de service utilisé par GPD Central, tous environnements confondus.</a:t>
             </a:r>
           </a:p>
           <a:p>
@@ -5033,7 +5033,7 @@
                 </a:solidFill>
                 <a:latin typeface="Segoe UI"/>
               </a:rPr>
-              <a:t>Un en-tête Origin est-il présent ?  •  grant_type  •  client_id  •  URI de redirection  •  méthode d'authentification du client</a:t>
+              <a:t>Y compris toute inscription confidentielle web/API absente des trois exports « spa » que nous détenons.</a:t>
             </a:r>
           </a:p>
           <a:p>
@@ -5049,7 +5049,7 @@
                 </a:solidFill>
                 <a:latin typeface="Segoe UI"/>
               </a:rPr>
-              <a:t>Indicateurs de présence ou empreintes SHA-256 uniquement. Jamais de codes, jetons, secrets ou assertions bruts.</a:t>
+              <a:t>Une seule réponse sépare les deux explications restantes. C'est la voie la plus rapide vers une configuration prise en charge.</a:t>
             </a:r>
           </a:p>
         </p:txBody>
@@ -5172,7 +5172,7 @@
                 </a:solidFill>
                 <a:latin typeface="Segoe UI"/>
               </a:rPr>
-              <a:t>Q8 — inventaire complet des inscriptions</a:t>
+              <a:t>Q7 — une capture /token caviardée</a:t>
             </a:r>
           </a:p>
         </p:txBody>
@@ -5211,7 +5211,7 @@
                 </a:solidFill>
                 <a:latin typeface="Segoe UI"/>
               </a:rPr>
-              <a:t>Chaque inscription d'application et principal de service utilisé par GPD Central, tous environnements confondus.</a:t>
+              <a:t>Pour une transaction réussie et une transaction en échec :</a:t>
             </a:r>
           </a:p>
           <a:p>
@@ -5227,7 +5227,7 @@
                 </a:solidFill>
                 <a:latin typeface="Segoe UI"/>
               </a:rPr>
-              <a:t>Y compris toute inscription confidentielle web/API absente des trois exports « spa » que nous détenons.</a:t>
+              <a:t>Un en-tête Origin est-il présent ?  •  grant_type  •  client_id  •  URI de redirection  •  méthode d'authentification du client</a:t>
             </a:r>
           </a:p>
           <a:p>
@@ -5243,7 +5243,7 @@
                 </a:solidFill>
                 <a:latin typeface="Segoe UI"/>
               </a:rPr>
-              <a:t>Promue au même rang de priorité par la découverte côté serveur.</a:t>
+              <a:t>Indicateurs de présence ou empreintes SHA-256 uniquement. Jamais de codes, jetons, secrets ou assertions bruts.</a:t>
             </a:r>
           </a:p>
         </p:txBody>
@@ -5278,7 +5278,7 @@
                 </a:solidFill>
                 <a:latin typeface="Segoe UI"/>
               </a:rPr>
-              <a:t>Également ouvertes : Q1 flux prévu  •  Q4 plages de sortie AWS  •  Q5 conformité d'appareil inter-locataires  •  Q6 compatibilité avec la liaison de jeton  •  Q9 parité Central / Conseiller</a:t>
+              <a:t>Également ouvertes : Q13 bibliothèque d'authentification et feuille de route .NET  •  Q10 ampleur du changement  •  Q12 acheminer les appels Entra par le VPN site à site existant  •  Q4 plages de sortie AWS  •  Q9 Conseiller partage-t-il quoi que ce soit avec Central ?</a:t>
             </a:r>
           </a:p>
         </p:txBody>
@@ -5310,7 +5310,7 @@
                 <a:latin typeface="Segoe UI"/>
                 <a:hlinkClick r:id="rId2"/>
               </a:rPr>
-              <a:t>▶  Liste complète des questions Q1–Q9 sur GitHub →</a:t>
+              <a:t>▶  Liste complète des questions Q1–Q14 sur GitHub →</a:t>
             </a:r>
           </a:p>
         </p:txBody>
@@ -5371,7 +5371,7 @@
                 </a:solidFill>
                 <a:latin typeface="Segoe UI"/>
               </a:rPr>
-              <a:t>UNE FOIS LA BIFURCATION RÉGLÉE</a:t>
+              <a:t>HUIT VOIES, CLASSÉES</a:t>
             </a:r>
           </a:p>
         </p:txBody>
@@ -5498,7 +5498,7 @@
                 </a:solidFill>
                 <a:latin typeface="Segoe UI"/>
               </a:rPr>
-              <a:t>Établir le type d'octroi d'abord.</a:t>
+              <a:t>Vérifier d'abord la parité des locataires — Desjardins seul.</a:t>
             </a:r>
             <a:r>
               <a:rPr sz="1564" b="0">
@@ -5507,7 +5507,7 @@
                 </a:solidFill>
                 <a:latin typeface="Segoe UI"/>
               </a:rPr>
-              <a:t> Aucun changement d'accès conditionnel, aucune liste d'autorisation d'IP AWS et aucune obligation d'OBO tant que l'octroi n'est pas connu.</a:t>
+              <a:t> Comparer la portée de l'accès conditionnel appliqué à Central en production et en préproduction. Aucune dépendance au fournisseur, et cela pourrait tout régler.</a:t>
             </a:r>
           </a:p>
           <a:p>
@@ -5532,7 +5532,7 @@
                 </a:solidFill>
                 <a:latin typeface="Segoe UI"/>
               </a:rPr>
-              <a:t>Branche A → inscrire un client confidentiel « web ».</a:t>
+              <a:t>Acheminer les appels Entra par le VPN site à site existant (Q12).</a:t>
             </a:r>
             <a:r>
               <a:rPr sz="1564" b="0">
@@ -5541,7 +5541,7 @@
                 </a:solidFill>
                 <a:latin typeface="Segoe UI"/>
               </a:rPr>
-              <a:t> Un certificat du côté de Croesus. Le plus petit changement possible ; aucun changement de politique chez Desjardins.</a:t>
+              <a:t> La requête /token sort alors d'une adresse appartenant à Desjardins. Aucun changement de code chez Croesus — le levier à court terme le plus fort.</a:t>
             </a:r>
           </a:p>
           <a:p>
@@ -5566,7 +5566,7 @@
                 </a:solidFill>
                 <a:latin typeface="Segoe UI"/>
               </a:rPr>
-              <a:t>Branche B → circonscrire à l'inscription divulguée.</a:t>
+              <a:t>Corriger la forme de l'inscription — spa → web.</a:t>
             </a:r>
             <a:r>
               <a:rPr sz="1564" b="0">
@@ -5575,7 +5575,7 @@
                 </a:solidFill>
                 <a:latin typeface="Segoe UI"/>
               </a:rPr>
-              <a:t> Appliquer toute accommodation à ce principal de service précis plutôt qu'à une large plage d'IP.</a:t>
+              <a:t> Par étapes : un secret client le prouve sans bibliothèque ni montée de version ; un certificat le durcit ensuite. Par locataire, donc Desjardins peut avancer en premier.</a:t>
             </a:r>
           </a:p>
           <a:p>
@@ -5609,7 +5609,7 @@
                 </a:solidFill>
                 <a:latin typeface="Segoe UI"/>
               </a:rPr>
-              <a:t> « Approuver les appareils conformes » entre locataires ne s'applique qu'à une connexion d'invité B2B, et le volet bloqué est un appel côté serveur sans aucun contexte d'appareil.</a:t>
+              <a:t> « Approuver les appareils conformes » entre locataires ne s'applique qu'à une connexion d'invité B2B. Les postes ne joignent qu'un seul locataire — la production — donc en préproduction « exiger un appareil conforme » est insatisfiable, et non simplement sévère.</a:t>
             </a:r>
           </a:p>
           <a:p>
@@ -5634,7 +5634,7 @@
                 </a:solidFill>
                 <a:latin typeface="Segoe UI"/>
               </a:rPr>
-              <a:t>On-Behalf-Of est une option, pas une obligation.</a:t>
+              <a:t>Un emplacement nommé est une condition, pas un octroi.</a:t>
             </a:r>
             <a:r>
               <a:rPr sz="1564" b="0">
@@ -5643,7 +5643,7 @@
                 </a:solidFill>
                 <a:latin typeface="Segoe UI"/>
               </a:rPr>
-              <a:t> Cela ne s'applique que si un véritable intermédiaire confidentiel est démontré — ce qui exige une étendue d'API exposée et un justificatif.</a:t>
+              <a:t> Les contrôles d'octroi se combinent avec ET : un emplacement approuvé ne satisfait pas une exigence d'appareil conforme. On-Behalf-Of reste une option, pas une obligation.</a:t>
             </a:r>
           </a:p>
         </p:txBody>
@@ -5890,7 +5890,7 @@
                 </a:solidFill>
                 <a:latin typeface="Segoe UI"/>
               </a:rPr>
-              <a:t>La bifurcation d'inscription :</a:t>
+              <a:t>L'erreur de type d'inscription :</a:t>
             </a:r>
             <a:r>
               <a:rPr sz="1472" b="0">
@@ -5899,7 +5899,7 @@
                 </a:solidFill>
                 <a:latin typeface="Segoe UI"/>
               </a:rPr>
-              <a:t> un panneau explique « spa » contre « web » et le comportement AADSTS9002327, avec des liens directs vers Q7 et Q8.</a:t>
+              <a:t> un panneau explique « spa » contre « web » et le comportement AADSTS9002327, avec des liens directs vers Q8 et Q7.</a:t>
             </a:r>
           </a:p>
           <a:p>
@@ -6389,7 +6389,7 @@
                           </a:solidFill>
                           <a:latin typeface="Segoe UI"/>
                         </a:rPr>
-                        <a:t>Interroger les journaux de connexion Entra sur le volet côté serveur : succès ou AADSTS9002327</a:t>
+                        <a:t>Comparer la portée de l'accès conditionnel pour Central entre production et préproduction</a:t>
                       </a:r>
                     </a:p>
                   </a:txBody>
@@ -6433,7 +6433,7 @@
                           </a:solidFill>
                           <a:latin typeface="Segoe UI"/>
                         </a:rPr>
-                        <a:t>Réduit la bifurcation sans le fournisseur</a:t>
+                        <a:t>Peut tout régler — sans attendre le fournisseur</a:t>
                       </a:r>
                     </a:p>
                   </a:txBody>
@@ -6479,7 +6479,7 @@
                           </a:solidFill>
                           <a:latin typeface="Segoe UI"/>
                         </a:rPr>
-                        <a:t>Fournir une capture /token caviardée (empreintes ou présence seulement)</a:t>
+                        <a:t>Fournir l'inventaire complet des inscriptions et principaux de service</a:t>
                       </a:r>
                     </a:p>
                   </a:txBody>
@@ -6523,7 +6523,7 @@
                           </a:solidFill>
                           <a:latin typeface="Segoe UI"/>
                         </a:rPr>
-                        <a:t>Q7</a:t>
+                        <a:t>Q8 — prioritaire</a:t>
                       </a:r>
                     </a:p>
                   </a:txBody>
@@ -6569,7 +6569,7 @@
                           </a:solidFill>
                           <a:latin typeface="Segoe UI"/>
                         </a:rPr>
-                        <a:t>Fournir l'inventaire complet des inscriptions et principaux de service</a:t>
+                        <a:t>Fournir une capture /token caviardée (empreintes ou présence seulement)</a:t>
                       </a:r>
                     </a:p>
                   </a:txBody>
@@ -6613,7 +6613,7 @@
                           </a:solidFill>
                           <a:latin typeface="Segoe UI"/>
                         </a:rPr>
-                        <a:t>Q8</a:t>
+                        <a:t>Q7</a:t>
                       </a:r>
                     </a:p>
                   </a:txBody>
@@ -6659,7 +6659,7 @@
                           </a:solidFill>
                           <a:latin typeface="Segoe UI"/>
                         </a:rPr>
-                        <a:t>Fournir les plages d'IP de sortie AWS et la définition du flux prévu</a:t>
+                        <a:t>Confirmer la bibliothèque d'authentification et toute montée de version .NET prévue</a:t>
                       </a:r>
                     </a:p>
                   </a:txBody>
@@ -6703,7 +6703,7 @@
                           </a:solidFill>
                           <a:latin typeface="Segoe UI"/>
                         </a:rPr>
-                        <a:t>Q4, Q1</a:t>
+                        <a:t>Q13</a:t>
                       </a:r>
                     </a:p>
                   </a:txBody>
@@ -6749,7 +6749,7 @@
                           </a:solidFill>
                           <a:latin typeface="Segoe UI"/>
                         </a:rPr>
-                        <a:t>Choisir la remédiation minimale une fois la branche connue</a:t>
+                        <a:t>Évaluer l'acheminement des appels Entra par le VPN site à site existant</a:t>
                       </a:r>
                     </a:p>
                   </a:txBody>
@@ -6793,7 +6793,7 @@
                           </a:solidFill>
                           <a:latin typeface="Segoe UI"/>
                         </a:rPr>
-                        <a:t>L'escalade</a:t>
+                        <a:t>Q12 — déblocage le plus rapide</a:t>
                       </a:r>
                     </a:p>
                   </a:txBody>
@@ -6838,7 +6838,7 @@
                 </a:solidFill>
                 <a:latin typeface="Segoe UI"/>
               </a:rPr>
-              <a:t>Garde-fou d'ici là : ne pas modifier l'accès conditionnel, ne pas mettre les IP de sortie AWS en liste d'autorisation, et ne pas imposer On-Behalf-Of.</a:t>
+              <a:t>Garde-fou d'ici là : ne pas modifier l'accès conditionnel, ne pas mettre les IP de sortie AWS en liste d'autorisation, ne pas imposer On-Behalf-Of, et ne rien généraliser à Conseiller.</a:t>
             </a:r>
           </a:p>
         </p:txBody>
@@ -7010,7 +7010,7 @@
                 <a:latin typeface="Segoe UI"/>
                 <a:hlinkClick r:id="rId2"/>
               </a:rPr>
-              <a:t>▶  Liste des questions Q1–Q9 (dossier d'escalade)</a:t>
+              <a:t>▶  Constats de la séance et les huit voies — COMMENCER ICI</a:t>
             </a:r>
           </a:p>
         </p:txBody>
@@ -7042,7 +7042,7 @@
                 <a:latin typeface="Segoe UI"/>
                 <a:hlinkClick r:id="rId3"/>
               </a:rPr>
-              <a:t>▶  Dossier d'escalade — document complet</a:t>
+              <a:t>▶  Voies et contournements (R1–R8)</a:t>
             </a:r>
           </a:p>
         </p:txBody>
@@ -7074,7 +7074,7 @@
                 <a:latin typeface="Segoe UI"/>
                 <a:hlinkClick r:id="rId4"/>
               </a:rPr>
-              <a:t>▶  Analyse complète — README</a:t>
+              <a:t>▶  Liste des questions Q1–Q14 (dossier d'escalade)</a:t>
             </a:r>
           </a:p>
         </p:txBody>
@@ -7106,7 +7106,7 @@
                 <a:latin typeface="Segoe UI"/>
                 <a:hlinkClick r:id="rId5"/>
               </a:rPr>
-              <a:t>▶  Qui peut capturer l'en-tête Origin de /token</a:t>
+              <a:t>▶  Dossier d'escalade — document complet</a:t>
             </a:r>
           </a:p>
         </p:txBody>
@@ -7138,7 +7138,7 @@
                 <a:latin typeface="Segoe UI"/>
                 <a:hlinkClick r:id="rId6"/>
               </a:rPr>
-              <a:t>▶  Récit de la preuve — correspondance question par question</a:t>
+              <a:t>▶  Analyse complète — README</a:t>
             </a:r>
           </a:p>
         </p:txBody>
@@ -7170,7 +7170,7 @@
                 <a:latin typeface="Segoe UI"/>
                 <a:hlinkClick r:id="rId7"/>
               </a:rPr>
-              <a:t>▶  Guide de démonstration On-Behalf-Of</a:t>
+              <a:t>▶  Qui peut capturer l'en-tête Origin de /token</a:t>
             </a:r>
           </a:p>
         </p:txBody>
@@ -7202,7 +7202,7 @@
                 <a:latin typeface="Segoe UI"/>
                 <a:hlinkClick r:id="rId8"/>
               </a:rPr>
-              <a:t>▶  Requêtes KQL de preuve</a:t>
+              <a:t>▶  Récit de la preuve — correspondance question par question</a:t>
             </a:r>
           </a:p>
         </p:txBody>
@@ -7234,7 +7234,7 @@
                 <a:latin typeface="Segoe UI"/>
                 <a:hlinkClick r:id="rId9"/>
               </a:rPr>
-              <a:t>▶  Dépôt — devopsabcs-engineering/croesus</a:t>
+              <a:t>▶  Guide de démonstration On-Behalf-Of</a:t>
             </a:r>
           </a:p>
         </p:txBody>
@@ -7265,6 +7265,38 @@
               <a:rPr sz="1472" b="1">
                 <a:latin typeface="Segoe UI"/>
                 <a:hlinkClick r:id="rId10"/>
+              </a:rPr>
+              <a:t>▶  Requêtes KQL de preuve</a:t>
+            </a:r>
+          </a:p>
+        </p:txBody>
+      </p:sp>
+      <p:sp>
+        <p:nvSpPr>
+          <p:cNvPr id="14" name="TextBox 13"/>
+          <p:cNvSpPr txBox="1"/>
+          <p:nvPr/>
+        </p:nvSpPr>
+        <p:spPr>
+          <a:xfrm>
+            <a:off x="777240" y="5989320"/>
+            <a:ext cx="10515600" cy="384048"/>
+          </a:xfrm>
+          <a:prstGeom prst="rect">
+            <a:avLst/>
+          </a:prstGeom>
+          <a:noFill/>
+        </p:spPr>
+        <p:txBody>
+          <a:bodyPr wrap="square">
+            <a:spAutoFit/>
+          </a:bodyPr>
+          <a:lstStyle/>
+          <a:p>
+            <a:r>
+              <a:rPr sz="1472" b="1">
+                <a:latin typeface="Segoe UI"/>
+                <a:hlinkClick r:id="rId11"/>
               </a:rPr>
               <a:t>▶  Application de démonstration en direct</a:t>
             </a:r>
@@ -7789,7 +7821,7 @@
                 </a:solidFill>
                 <a:latin typeface="Segoe UI"/>
               </a:rPr>
-              <a:t>Le blocage d'accès conditionnel est </a:t>
+              <a:t>Central est une </a:t>
             </a:r>
             <a:r>
               <a:rPr sz="1564" b="1">
@@ -7798,7 +7830,7 @@
                 </a:solidFill>
                 <a:latin typeface="Segoe UI"/>
               </a:rPr>
-              <a:t>correct par conception</a:t>
+              <a:t>application multipage rendue côté serveur</a:t>
             </a:r>
             <a:r>
               <a:rPr sz="1564" b="0">
@@ -7807,7 +7839,7 @@
                 </a:solidFill>
                 <a:latin typeface="Segoe UI"/>
               </a:rPr>
-              <a:t>. L'accès conditionnel réagit à l'origine et au contexte de la requête, pas au type d'octroi.</a:t>
+              <a:t> — environ 130 pages .aspx sur .NET Framework 4.5.2. Confirmé par le fournisseur. Ce n'est pas une SPA.</a:t>
             </a:r>
           </a:p>
           <a:p>
@@ -7832,7 +7864,7 @@
                 </a:solidFill>
                 <a:latin typeface="Segoe UI"/>
               </a:rPr>
-              <a:t>L'échange du code sur /token est désormais </a:t>
+              <a:t>La plateforme « spa » des trois inscriptions est donc une </a:t>
             </a:r>
             <a:r>
               <a:rPr sz="1564" b="1">
@@ -7841,7 +7873,7 @@
                 </a:solidFill>
                 <a:latin typeface="Segoe UI"/>
               </a:rPr>
-              <a:t>confirmé côté serveur</a:t>
+              <a:t>erreur de type</a:t>
             </a:r>
             <a:r>
               <a:rPr sz="1564" b="0">
@@ -7850,7 +7882,7 @@
                 </a:solidFill>
                 <a:latin typeface="Segoe UI"/>
               </a:rPr>
-              <a:t> — une trace de navigateur de Desjardins montre /authorize mais aucun /token. Cela corrobore Croesus.</a:t>
+              <a:t>, non une description. Central est déjà un Backend-for-Frontend ; c'est la plateforme « web » qui le dit.</a:t>
             </a:r>
           </a:p>
           <a:p>
@@ -7875,7 +7907,7 @@
                 </a:solidFill>
                 <a:latin typeface="Segoe UI"/>
               </a:rPr>
-              <a:t>Le type d'octroi n'est </a:t>
+              <a:t>Central fonctionne en production : l'échange côté serveur </a:t>
             </a:r>
             <a:r>
               <a:rPr sz="1564" b="1">
@@ -7884,7 +7916,7 @@
                 </a:solidFill>
                 <a:latin typeface="Segoe UI"/>
               </a:rPr>
-              <a:t>toujours pas établi</a:t>
+              <a:t>réussit</a:t>
             </a:r>
             <a:r>
               <a:rPr sz="1564" b="0">
@@ -7893,7 +7925,16 @@
                 </a:solidFill>
                 <a:latin typeface="Segoe UI"/>
               </a:rPr>
-              <a:t> à partir d'une requête capturée. /token est le point de terminaison normal pour l'échange du code et le renouvellement — ce n'est pas une preuve d'On-Behalf-Of.</a:t>
+              <a:t> alors qu'Entra devrait le refuser. Deux explications subsistent — un en-tête Origin synthétisé, ou une inscription « web » non divulguée. </a:t>
+            </a:r>
+            <a:r>
+              <a:rPr sz="1564" b="1">
+                <a:solidFill>
+                  <a:srgbClr val="1A1A1A"/>
+                </a:solidFill>
+                <a:latin typeface="Segoe UI"/>
+              </a:rPr>
+              <a:t>Q8 est la demande prioritaire.</a:t>
             </a:r>
           </a:p>
           <a:p>
@@ -7918,7 +7959,7 @@
                 </a:solidFill>
                 <a:latin typeface="Segoe UI"/>
               </a:rPr>
-              <a:t>La mention « Unbound (1008) » est un </a:t>
+              <a:t>L'écart production / préproduction reste </a:t>
             </a:r>
             <a:r>
               <a:rPr sz="1564" b="1">
@@ -7927,7 +7968,7 @@
                 </a:solidFill>
                 <a:latin typeface="Segoe UI"/>
               </a:rPr>
-              <a:t>état de liaison d'appareil et de session</a:t>
+              <a:t>inexpliqué</a:t>
             </a:r>
             <a:r>
               <a:rPr sz="1564" b="0">
@@ -7936,7 +7977,7 @@
                 </a:solidFill>
                 <a:latin typeface="Segoe UI"/>
               </a:rPr>
-              <a:t>, non une preuve de rejeu de jeton et non un indicateur du type d'octroi.</a:t>
+              <a:t> — la requête bloquée ne porte aucun contexte d'appareil dans l'un ni l'autre locataire. Desjardins peut trancher seul, cette semaine.</a:t>
             </a:r>
           </a:p>
           <a:p>
@@ -7961,7 +8002,7 @@
                 </a:solidFill>
                 <a:latin typeface="Segoe UI"/>
               </a:rPr>
-              <a:t>Prochaine étape : régler la bifurcation avec </a:t>
+              <a:t>Le blocage d'accès conditionnel est </a:t>
             </a:r>
             <a:r>
               <a:rPr sz="1564" b="1">
@@ -7970,7 +8011,7 @@
                 </a:solidFill>
                 <a:latin typeface="Segoe UI"/>
               </a:rPr>
-              <a:t>Q7 et Q8</a:t>
+              <a:t>correct par conception</a:t>
             </a:r>
             <a:r>
               <a:rPr sz="1564" b="0">
@@ -7979,7 +8020,7 @@
                 </a:solidFill>
                 <a:latin typeface="Segoe UI"/>
               </a:rPr>
-              <a:t>. Ne rien modifier dans l'accès conditionnel d'ici là.</a:t>
+              <a:t>. La mention « Unbound (1008) » est un état de liaison, non une preuve de rejeu ni un indicateur du type d'octroi.</a:t>
             </a:r>
           </a:p>
         </p:txBody>
@@ -9148,7 +9189,7 @@
                 </a:solidFill>
                 <a:latin typeface="Segoe UI"/>
               </a:rPr>
-              <a:t>HYPOTHÈSE À VÉRIFIER</a:t>
+              <a:t>CE QUI EN DÉCOULE</a:t>
             </a:r>
           </a:p>
         </p:txBody>
@@ -9183,7 +9224,7 @@
                 </a:solidFill>
                 <a:latin typeface="Segoe UI"/>
               </a:rPr>
-              <a:t>La bifurcation que cela crée</a:t>
+              <a:t>L'erreur de type, et les deux explications restantes</a:t>
             </a:r>
           </a:p>
         </p:txBody>
@@ -9262,7 +9303,7 @@
                 </a:solidFill>
                 <a:latin typeface="Segoe UI"/>
               </a:rPr>
-              <a:t>Microsoft Entra rejette l'échange côté serveur d'un code d'autorisation « spa » avec l'erreur AADSTS9002327. Un échange côté serveur et une inscription uniquement « spa » ne peuvent pas coexister.</a:t>
+              <a:t>Entra rejette l'échange côté serveur d'un code d'autorisation « spa » avec l'erreur AADSTS9002327. Or Central fonctionne en production : l'échange réussit. Deux explications subsistent.</a:t>
             </a:r>
           </a:p>
         </p:txBody>
@@ -9385,7 +9426,7 @@
                 </a:solidFill>
                 <a:latin typeface="Segoe UI"/>
               </a:rPr>
-              <a:t>Branche A — l'échange ÉCHOUE</a:t>
+              <a:t>1 — Un en-tête Origin synthétisé</a:t>
             </a:r>
           </a:p>
         </p:txBody>
@@ -9424,7 +9465,7 @@
                 </a:solidFill>
                 <a:latin typeface="Segoe UI"/>
               </a:rPr>
-              <a:t>Entra retourne AADSTS9002327.</a:t>
+              <a:t>Un POST de serveur à serveur n'envoie aucun Origin de lui-même.</a:t>
             </a:r>
           </a:p>
           <a:p>
@@ -9440,7 +9481,7 @@
                 </a:solidFill>
                 <a:latin typeface="Segoe UI"/>
               </a:rPr>
-              <a:t>Un client public « spa » ne peut pas servir un échange sans en-tête Origin. La forme d'inscription requise est absente.</a:t>
+              <a:t>S'il y en a un, c'est le code applicatif qui l'ajoute — et un code de type « spa » survit à une règle qu'Entra a écrite pour le refuser.</a:t>
             </a:r>
           </a:p>
           <a:p>
@@ -9456,7 +9497,7 @@
                 </a:solidFill>
                 <a:latin typeface="Segoe UI"/>
               </a:rPr>
-              <a:t>Correctif : Croesus inscrit un client confidentiel « web » avec un certificat.</a:t>
+              <a:t>Correctif : inscrire Central comme client confidentiel « web ». Le prouver avec un secret client — sans bibliothèque ni montée de version — puis durcir avec un certificat.</a:t>
             </a:r>
           </a:p>
         </p:txBody>
@@ -9579,7 +9620,7 @@
                 </a:solidFill>
                 <a:latin typeface="Segoe UI"/>
               </a:rPr>
-              <a:t>Branche B — l'échange RÉUSSIT</a:t>
+              <a:t>2 — Une inscription « web » non divulguée</a:t>
             </a:r>
           </a:p>
         </p:txBody>
@@ -9618,7 +9659,7 @@
                 </a:solidFill>
                 <a:latin typeface="Segoe UI"/>
               </a:rPr>
-              <a:t>Aucun AADSTS9002327 dans les journaux.</a:t>
+              <a:t>Le serveur dorsal s'authentifie hors de nos trois exports.</a:t>
             </a:r>
           </a:p>
           <a:p>
@@ -9634,7 +9675,7 @@
                 </a:solidFill>
                 <a:latin typeface="Segoe UI"/>
               </a:rPr>
-              <a:t>Le serveur dorsal s'authentifie alors avec une inscription hors des trois exports « spa » qui nous ont été remis.</a:t>
+              <a:t>La forme est alors déjà correcte, et elle ne nous a simplement jamais été montrée.</a:t>
             </a:r>
           </a:p>
           <a:p>
@@ -9685,7 +9726,7 @@
                 </a:solidFill>
                 <a:latin typeface="Segoe UI"/>
               </a:rPr>
-              <a:t>Réserve : si l'accès conditionnel bloque le volet en amont, les journaux affichent plutôt un code d'échec d'accès conditionnel — ce qui ne tranche pas la question.</a:t>
+              <a:t>Par ailleurs, et toujours ouvert : la requête bloquée ne porte aucun contexte d'appareil dans l'UN NI L'AUTRE locataire, et pourtant la production passe. C'est à Desjardins de trancher, à partir de son propre inventaire de stratégies et de ses journaux de connexion.</a:t>
             </a:r>
           </a:p>
         </p:txBody>
@@ -9840,7 +9881,7 @@
         </p:nvGraphicFramePr>
         <p:xfrm>
           <a:off x="685800" y="1920240"/>
-          <a:ext cx="10835640" cy="3703320"/>
+          <a:ext cx="10835640" cy="4361688"/>
         </p:xfrm>
         <a:graphic>
           <a:graphicData uri="http://schemas.openxmlformats.org/drawingml/2006/table">
@@ -9853,7 +9894,7 @@
                 <a:gridCol w="4206240"/>
                 <a:gridCol w="4160520"/>
               </a:tblGrid>
-              <a:tr h="617220">
+              <a:tr h="623098">
                 <a:tc>
                   <a:txBody>
                     <a:bodyPr/>
@@ -9921,7 +9962,7 @@
                   </a:tcPr>
                 </a:tc>
               </a:tr>
-              <a:tr h="617220">
+              <a:tr h="623098">
                 <a:tc>
                   <a:txBody>
                     <a:bodyPr/>
@@ -9934,7 +9975,7 @@
                           </a:solidFill>
                           <a:latin typeface="Segoe UI"/>
                         </a:rPr>
-                        <a:t>Justificatif</a:t>
+                        <a:t>Décrit</a:t>
                       </a:r>
                     </a:p>
                   </a:txBody>
@@ -9956,7 +9997,7 @@
                           </a:solidFill>
                           <a:latin typeface="Segoe UI"/>
                         </a:rPr>
-                        <a:t>Aucun — ni secret, ni certificat</a:t>
+                        <a:t>Un client public de navigateur</a:t>
                       </a:r>
                     </a:p>
                   </a:txBody>
@@ -9978,7 +10019,7 @@
                           </a:solidFill>
                           <a:latin typeface="Segoe UI"/>
                         </a:rPr>
-                        <a:t>Secret ou certificat requis</a:t>
+                        <a:t>Une application web rendue côté serveur / BFF</a:t>
                       </a:r>
                     </a:p>
                   </a:txBody>
@@ -9989,7 +10030,7 @@
                   </a:tcPr>
                 </a:tc>
               </a:tr>
-              <a:tr h="617220">
+              <a:tr h="623098">
                 <a:tc>
                   <a:txBody>
                     <a:bodyPr/>
@@ -10002,7 +10043,7 @@
                           </a:solidFill>
                           <a:latin typeface="Segoe UI"/>
                         </a:rPr>
-                        <a:t>Échange d'un code</a:t>
+                        <a:t>Justificatif</a:t>
                       </a:r>
                     </a:p>
                   </a:txBody>
@@ -10024,7 +10065,7 @@
                           </a:solidFill>
                           <a:latin typeface="Segoe UI"/>
                         </a:rPr>
-                        <a:t>Uniquement depuis une requête de navigateur cross-origin (en-tête Origin)</a:t>
+                        <a:t>Aucun — ni secret, ni certificat</a:t>
                       </a:r>
                     </a:p>
                   </a:txBody>
@@ -10046,7 +10087,7 @@
                           </a:solidFill>
                           <a:latin typeface="Segoe UI"/>
                         </a:rPr>
-                        <a:t>Depuis un serveur, sans en-tête Origin</a:t>
+                        <a:t>Secret ou certificat requis</a:t>
                       </a:r>
                     </a:p>
                   </a:txBody>
@@ -10057,7 +10098,7 @@
                   </a:tcPr>
                 </a:tc>
               </a:tr>
-              <a:tr h="617220">
+              <a:tr h="623098">
                 <a:tc>
                   <a:txBody>
                     <a:bodyPr/>
@@ -10070,7 +10111,7 @@
                           </a:solidFill>
                           <a:latin typeface="Segoe UI"/>
                         </a:rPr>
-                        <a:t>Échange côté serveur</a:t>
+                        <a:t>Échange d'un code</a:t>
                       </a:r>
                     </a:p>
                   </a:txBody>
@@ -10092,7 +10133,7 @@
                           </a:solidFill>
                           <a:latin typeface="Segoe UI"/>
                         </a:rPr>
-                        <a:t>Rejeté : AADSTS9002327</a:t>
+                        <a:t>Uniquement depuis une requête de navigateur cross-origin (en-tête Origin)</a:t>
                       </a:r>
                     </a:p>
                   </a:txBody>
@@ -10114,7 +10155,7 @@
                           </a:solidFill>
                           <a:latin typeface="Segoe UI"/>
                         </a:rPr>
-                        <a:t>Pris en charge</a:t>
+                        <a:t>Depuis un serveur, sans en-tête Origin</a:t>
                       </a:r>
                     </a:p>
                   </a:txBody>
@@ -10125,7 +10166,7 @@
                   </a:tcPr>
                 </a:tc>
               </a:tr>
-              <a:tr h="617220">
+              <a:tr h="623098">
                 <a:tc>
                   <a:txBody>
                     <a:bodyPr/>
@@ -10138,7 +10179,7 @@
                           </a:solidFill>
                           <a:latin typeface="Segoe UI"/>
                         </a:rPr>
-                        <a:t>Étendue d'API exposée</a:t>
+                        <a:t>Échange côté serveur</a:t>
                       </a:r>
                     </a:p>
                   </a:txBody>
@@ -10160,7 +10201,7 @@
                           </a:solidFill>
                           <a:latin typeface="Segoe UI"/>
                         </a:rPr>
-                        <a:t>Aucune dans les trois exports</a:t>
+                        <a:t>Rejeté : AADSTS9002327</a:t>
                       </a:r>
                     </a:p>
                   </a:txBody>
@@ -10182,7 +10223,7 @@
                           </a:solidFill>
                           <a:latin typeface="Segoe UI"/>
                         </a:rPr>
-                        <a:t>Requise pour On-Behalf-Of</a:t>
+                        <a:t>Pris en charge</a:t>
                       </a:r>
                     </a:p>
                   </a:txBody>
@@ -10193,7 +10234,7 @@
                   </a:tcPr>
                 </a:tc>
               </a:tr>
-              <a:tr h="617220">
+              <a:tr h="623098">
                 <a:tc>
                   <a:txBody>
                     <a:bodyPr/>
@@ -10206,7 +10247,7 @@
                           </a:solidFill>
                           <a:latin typeface="Segoe UI"/>
                         </a:rPr>
-                        <a:t>Ce que nous détenons</a:t>
+                        <a:t>Durée des jetons d'actualisation</a:t>
                       </a:r>
                     </a:p>
                   </a:txBody>
@@ -10228,7 +10269,7 @@
                           </a:solidFill>
                           <a:latin typeface="Segoe UI"/>
                         </a:rPr>
-                        <a:t>Les trois : dev-dev, dev-prod, prod-prod</a:t>
+                        <a:t>Plafonnée à 24 heures, non glissante</a:t>
                       </a:r>
                     </a:p>
                   </a:txBody>
@@ -10250,13 +10291,81 @@
                           </a:solidFill>
                           <a:latin typeface="Segoe UI"/>
                         </a:rPr>
-                        <a:t>Aucune divulguée</a:t>
+                        <a:t>Sans ce plafond</a:t>
                       </a:r>
                     </a:p>
                   </a:txBody>
                   <a:tcPr anchor="ctr">
                     <a:solidFill>
                       <a:srgbClr val="FFFFFF"/>
+                    </a:solidFill>
+                  </a:tcPr>
+                </a:tc>
+              </a:tr>
+              <a:tr h="623100">
+                <a:tc>
+                  <a:txBody>
+                    <a:bodyPr/>
+                    <a:lstStyle/>
+                    <a:p>
+                      <a:r>
+                        <a:rPr sz="1288">
+                          <a:solidFill>
+                            <a:srgbClr val="1A1A1A"/>
+                          </a:solidFill>
+                          <a:latin typeface="Segoe UI"/>
+                        </a:rPr>
+                        <a:t>Ce qu'est réellement Central</a:t>
+                      </a:r>
+                    </a:p>
+                  </a:txBody>
+                  <a:tcPr anchor="ctr">
+                    <a:solidFill>
+                      <a:srgbClr val="F2F6FA"/>
+                    </a:solidFill>
+                  </a:tcPr>
+                </a:tc>
+                <a:tc>
+                  <a:txBody>
+                    <a:bodyPr/>
+                    <a:lstStyle/>
+                    <a:p>
+                      <a:r>
+                        <a:rPr sz="1288">
+                          <a:solidFill>
+                            <a:srgbClr val="1A1A1A"/>
+                          </a:solidFill>
+                          <a:latin typeface="Segoe UI"/>
+                        </a:rPr>
+                        <a:t>Pas ceci</a:t>
+                      </a:r>
+                    </a:p>
+                  </a:txBody>
+                  <a:tcPr anchor="ctr">
+                    <a:solidFill>
+                      <a:srgbClr val="F2F6FA"/>
+                    </a:solidFill>
+                  </a:tcPr>
+                </a:tc>
+                <a:tc>
+                  <a:txBody>
+                    <a:bodyPr/>
+                    <a:lstStyle/>
+                    <a:p>
+                      <a:r>
+                        <a:rPr sz="1288">
+                          <a:solidFill>
+                            <a:srgbClr val="1A1A1A"/>
+                          </a:solidFill>
+                          <a:latin typeface="Segoe UI"/>
+                        </a:rPr>
+                        <a:t>Ceci — environ 130 pages .aspx</a:t>
+                      </a:r>
+                    </a:p>
+                  </a:txBody>
+                  <a:tcPr anchor="ctr">
+                    <a:solidFill>
+                      <a:srgbClr val="F2F6FA"/>
                     </a:solidFill>
                   </a:tcPr>
                 </a:tc>
@@ -10391,7 +10500,7 @@
                 </a:solidFill>
                 <a:latin typeface="Segoe UI"/>
               </a:rPr>
-              <a:t>La même bifurcation, en direct dans la démo</a:t>
+              <a:t>La même erreur de type, en direct dans la démo</a:t>
             </a:r>
           </a:p>
         </p:txBody>
@@ -10740,7 +10849,7 @@
                           </a:solidFill>
                           <a:latin typeface="Segoe UI"/>
                         </a:rPr>
-                        <a:t>En-tête Origin sur un appel /token côté navigateur</a:t>
+                        <a:t>Inventaire complet des inscriptions et principaux de service</a:t>
                       </a:r>
                     </a:p>
                   </a:txBody>
@@ -10762,7 +10871,7 @@
                           </a:solidFill>
                           <a:latin typeface="Segoe UI"/>
                         </a:rPr>
-                        <a:t>Desjardins — outils de développement du navigateur</a:t>
+                        <a:t>Croesus</a:t>
                       </a:r>
                     </a:p>
                   </a:txBody>
@@ -10784,7 +10893,7 @@
                           </a:solidFill>
                           <a:latin typeface="Segoe UI"/>
                         </a:rPr>
-                        <a:t>Écarté — aucun /token dans le HAR</a:t>
+                        <a:t>OUVERT — Q8, demande prioritaire</a:t>
                       </a:r>
                     </a:p>
                   </a:txBody>
@@ -10876,143 +10985,7 @@
                           </a:solidFill>
                           <a:latin typeface="Segoe UI"/>
                         </a:rPr>
-                        <a:t>Le second volet a-t-il réussi ou échoué avec AADSTS9002327 ?</a:t>
-                      </a:r>
-                    </a:p>
-                  </a:txBody>
-                  <a:tcPr anchor="ctr">
-                    <a:solidFill>
-                      <a:srgbClr val="FFFFFF"/>
-                    </a:solidFill>
-                  </a:tcPr>
-                </a:tc>
-                <a:tc>
-                  <a:txBody>
-                    <a:bodyPr/>
-                    <a:lstStyle/>
-                    <a:p>
-                      <a:r>
-                        <a:rPr sz="1196">
-                          <a:solidFill>
-                            <a:srgbClr val="1A1A1A"/>
-                          </a:solidFill>
-                          <a:latin typeface="Segoe UI"/>
-                        </a:rPr>
-                        <a:t>Desjardins — ses propres journaux de connexion Entra</a:t>
-                      </a:r>
-                    </a:p>
-                  </a:txBody>
-                  <a:tcPr anchor="ctr">
-                    <a:solidFill>
-                      <a:srgbClr val="FFFFFF"/>
-                    </a:solidFill>
-                  </a:tcPr>
-                </a:tc>
-                <a:tc>
-                  <a:txBody>
-                    <a:bodyPr/>
-                    <a:lstStyle/>
-                    <a:p>
-                      <a:r>
-                        <a:rPr sz="1196">
-                          <a:solidFill>
-                            <a:srgbClr val="1A1A1A"/>
-                          </a:solidFill>
-                          <a:latin typeface="Segoe UI"/>
-                        </a:rPr>
-                        <a:t>En cours</a:t>
-                      </a:r>
-                    </a:p>
-                  </a:txBody>
-                  <a:tcPr anchor="ctr">
-                    <a:solidFill>
-                      <a:srgbClr val="FFFFFF"/>
-                    </a:solidFill>
-                  </a:tcPr>
-                </a:tc>
-              </a:tr>
-              <a:tr h="617220">
-                <a:tc>
-                  <a:txBody>
-                    <a:bodyPr/>
-                    <a:lstStyle/>
-                    <a:p>
-                      <a:r>
-                        <a:rPr sz="1196">
-                          <a:solidFill>
-                            <a:srgbClr val="1A1A1A"/>
-                          </a:solidFill>
-                          <a:latin typeface="Segoe UI"/>
-                        </a:rPr>
-                        <a:t>Inventaire complet des inscriptions et principaux de service</a:t>
-                      </a:r>
-                    </a:p>
-                  </a:txBody>
-                  <a:tcPr anchor="ctr">
-                    <a:solidFill>
-                      <a:srgbClr val="F2F6FA"/>
-                    </a:solidFill>
-                  </a:tcPr>
-                </a:tc>
-                <a:tc>
-                  <a:txBody>
-                    <a:bodyPr/>
-                    <a:lstStyle/>
-                    <a:p>
-                      <a:r>
-                        <a:rPr sz="1196">
-                          <a:solidFill>
-                            <a:srgbClr val="1A1A1A"/>
-                          </a:solidFill>
-                          <a:latin typeface="Segoe UI"/>
-                        </a:rPr>
-                        <a:t>Croesus</a:t>
-                      </a:r>
-                    </a:p>
-                  </a:txBody>
-                  <a:tcPr anchor="ctr">
-                    <a:solidFill>
-                      <a:srgbClr val="F2F6FA"/>
-                    </a:solidFill>
-                  </a:tcPr>
-                </a:tc>
-                <a:tc>
-                  <a:txBody>
-                    <a:bodyPr/>
-                    <a:lstStyle/>
-                    <a:p>
-                      <a:r>
-                        <a:rPr sz="1196">
-                          <a:solidFill>
-                            <a:srgbClr val="1A1A1A"/>
-                          </a:solidFill>
-                          <a:latin typeface="Segoe UI"/>
-                        </a:rPr>
-                        <a:t>Ouvert — Q8</a:t>
-                      </a:r>
-                    </a:p>
-                  </a:txBody>
-                  <a:tcPr anchor="ctr">
-                    <a:solidFill>
-                      <a:srgbClr val="F2F6FA"/>
-                    </a:solidFill>
-                  </a:tcPr>
-                </a:tc>
-              </a:tr>
-              <a:tr h="617220">
-                <a:tc>
-                  <a:txBody>
-                    <a:bodyPr/>
-                    <a:lstStyle/>
-                    <a:p>
-                      <a:r>
-                        <a:rPr sz="1196">
-                          <a:solidFill>
-                            <a:srgbClr val="1A1A1A"/>
-                          </a:solidFill>
-                          <a:latin typeface="Segoe UI"/>
-                        </a:rPr>
-                        <a:t>Plages d'IP de sortie AWS, définition du flux prévu</a:t>
+                        <a:t>Quelle bibliothèque d'authentification, et montée .NET prévue ?</a:t>
                       </a:r>
                     </a:p>
                   </a:txBody>
@@ -11056,7 +11029,143 @@
                           </a:solidFill>
                           <a:latin typeface="Segoe UI"/>
                         </a:rPr>
-                        <a:t>Ouvert — Q4, Q1</a:t>
+                        <a:t>Ouvert — Q13</a:t>
+                      </a:r>
+                    </a:p>
+                  </a:txBody>
+                  <a:tcPr anchor="ctr">
+                    <a:solidFill>
+                      <a:srgbClr val="FFFFFF"/>
+                    </a:solidFill>
+                  </a:tcPr>
+                </a:tc>
+              </a:tr>
+              <a:tr h="617220">
+                <a:tc>
+                  <a:txBody>
+                    <a:bodyPr/>
+                    <a:lstStyle/>
+                    <a:p>
+                      <a:r>
+                        <a:rPr sz="1196">
+                          <a:solidFill>
+                            <a:srgbClr val="1A1A1A"/>
+                          </a:solidFill>
+                          <a:latin typeface="Segoe UI"/>
+                        </a:rPr>
+                        <a:t>Portée de l'accès conditionnel pour Central : prod vs préprod</a:t>
+                      </a:r>
+                    </a:p>
+                  </a:txBody>
+                  <a:tcPr anchor="ctr">
+                    <a:solidFill>
+                      <a:srgbClr val="F2F6FA"/>
+                    </a:solidFill>
+                  </a:tcPr>
+                </a:tc>
+                <a:tc>
+                  <a:txBody>
+                    <a:bodyPr/>
+                    <a:lstStyle/>
+                    <a:p>
+                      <a:r>
+                        <a:rPr sz="1196">
+                          <a:solidFill>
+                            <a:srgbClr val="1A1A1A"/>
+                          </a:solidFill>
+                          <a:latin typeface="Segoe UI"/>
+                        </a:rPr>
+                        <a:t>Desjardins — son inventaire de stratégies</a:t>
+                      </a:r>
+                    </a:p>
+                  </a:txBody>
+                  <a:tcPr anchor="ctr">
+                    <a:solidFill>
+                      <a:srgbClr val="F2F6FA"/>
+                    </a:solidFill>
+                  </a:tcPr>
+                </a:tc>
+                <a:tc>
+                  <a:txBody>
+                    <a:bodyPr/>
+                    <a:lstStyle/>
+                    <a:p>
+                      <a:r>
+                        <a:rPr sz="1196">
+                          <a:solidFill>
+                            <a:srgbClr val="1A1A1A"/>
+                          </a:solidFill>
+                          <a:latin typeface="Segoe UI"/>
+                        </a:rPr>
+                        <a:t>En cours — valeur la plus élevée</a:t>
+                      </a:r>
+                    </a:p>
+                  </a:txBody>
+                  <a:tcPr anchor="ctr">
+                    <a:solidFill>
+                      <a:srgbClr val="F2F6FA"/>
+                    </a:solidFill>
+                  </a:tcPr>
+                </a:tc>
+              </a:tr>
+              <a:tr h="617220">
+                <a:tc>
+                  <a:txBody>
+                    <a:bodyPr/>
+                    <a:lstStyle/>
+                    <a:p>
+                      <a:r>
+                        <a:rPr sz="1196">
+                          <a:solidFill>
+                            <a:srgbClr val="1A1A1A"/>
+                          </a:solidFill>
+                          <a:latin typeface="Segoe UI"/>
+                        </a:rPr>
+                        <a:t>En-tête Origin sur un appel /token côté navigateur</a:t>
+                      </a:r>
+                    </a:p>
+                  </a:txBody>
+                  <a:tcPr anchor="ctr">
+                    <a:solidFill>
+                      <a:srgbClr val="FFFFFF"/>
+                    </a:solidFill>
+                  </a:tcPr>
+                </a:tc>
+                <a:tc>
+                  <a:txBody>
+                    <a:bodyPr/>
+                    <a:lstStyle/>
+                    <a:p>
+                      <a:r>
+                        <a:rPr sz="1196">
+                          <a:solidFill>
+                            <a:srgbClr val="1A1A1A"/>
+                          </a:solidFill>
+                          <a:latin typeface="Segoe UI"/>
+                        </a:rPr>
+                        <a:t>Desjardins — outils de développement du navigateur</a:t>
+                      </a:r>
+                    </a:p>
+                  </a:txBody>
+                  <a:tcPr anchor="ctr">
+                    <a:solidFill>
+                      <a:srgbClr val="FFFFFF"/>
+                    </a:solidFill>
+                  </a:tcPr>
+                </a:tc>
+                <a:tc>
+                  <a:txBody>
+                    <a:bodyPr/>
+                    <a:lstStyle/>
+                    <a:p>
+                      <a:r>
+                        <a:rPr sz="1196">
+                          <a:solidFill>
+                            <a:srgbClr val="1A1A1A"/>
+                          </a:solidFill>
+                          <a:latin typeface="Segoe UI"/>
+                        </a:rPr>
+                        <a:t>Écarté — aucun /token dans le HAR</a:t>
                       </a:r>
                     </a:p>
                   </a:txBody>

</xml_diff>

<commit_message>
feat: Complete Phase 7 updates for Croesus registration evidence, including UI topology separation and documentation corrections
</commit_message>
<xml_diff>
--- a/docs/deck/croesus-session-deck-fr.pptx
+++ b/docs/deck/croesus-session-deck-fr.pptx
@@ -725,7 +725,7 @@
           <a:lstStyle/>
           <a:p>
             <a:r>
-              <a:t>Ordre de la démo : se connecter, appeler l'API, montrer le panneau de preuve, puis le bouton de rejeu, puis faire défiler jusqu'au panneau d'erreur de type d'inscription et cliquer vers Q8/Q7.</a:t>
+              <a:t>Ordre de la démo : se connecter, appeler l'API, montrer le panneau de preuve, puis le bouton de rejeu, puis faire défiler jusqu'au panneau de bifurcation d'inscription et cliquer vers Q8/Q7/Q15.</a:t>
             </a:r>
           </a:p>
         </p:txBody>
@@ -1355,7 +1355,7 @@
           <a:lstStyle/>
           <a:p>
             <a:r>
-              <a:t>Le panneau s'affiche sans connexion : il peut donc être présenté en partage d'écran. Q8, Q7 et la liste complète des questions sont cliquables directement depuis la page. L'interface de la démo est en anglais.</a:t>
+              <a:t>Le panneau s'affiche sans connexion : il peut donc être présenté en partage d'écran. Q8, Q7, Q15 et la liste complète des questions sont cliquables directement depuis la page. L'interface de la démo est en anglais.</a:t>
             </a:r>
           </a:p>
         </p:txBody>
@@ -4651,7 +4651,7 @@
                 <a:latin typeface="Segoe UI"/>
                 <a:hlinkClick r:id="rId2"/>
               </a:rPr>
-              <a:t>▶  Constats de la séance et les huit voies</a:t>
+              <a:t>▶  Constats de la séance et les neuf voies</a:t>
             </a:r>
           </a:p>
         </p:txBody>
@@ -4683,7 +4683,7 @@
                 <a:latin typeface="Segoe UI"/>
                 <a:hlinkClick r:id="rId3"/>
               </a:rPr>
-              <a:t>▶  Liste des questions (Q1–Q14) sur GitHub</a:t>
+              <a:t>▶  Liste des questions (Q1–Q15) sur GitHub</a:t>
             </a:r>
           </a:p>
         </p:txBody>
@@ -5278,7 +5278,7 @@
                 </a:solidFill>
                 <a:latin typeface="Segoe UI"/>
               </a:rPr>
-              <a:t>Également ouvertes : Q13 bibliothèque d'authentification et feuille de route .NET  •  Q10 ampleur du changement  •  Q12 acheminer les appels Entra par le VPN site à site existant  •  Q4 plages de sortie AWS  •  Q9 Conseiller partage-t-il quoi que ce soit avec Central ?</a:t>
+              <a:t>Également ouvertes : Q15 preuve de l'interface et du BFF  •  Q13 bibliothèque d'authentification et feuille de route .NET  •  Q10 ampleur du changement  •  Q12 acheminer les appels Entra par le VPN site à site existant  •  Q4 plages de sortie AWS  •  Q9 Conseiller partage-t-il quoi que ce soit avec Central ?</a:t>
             </a:r>
           </a:p>
         </p:txBody>
@@ -5310,7 +5310,7 @@
                 <a:latin typeface="Segoe UI"/>
                 <a:hlinkClick r:id="rId2"/>
               </a:rPr>
-              <a:t>▶  Liste complète des questions Q1–Q14 sur GitHub →</a:t>
+              <a:t>▶  Liste complète des questions Q1–Q15 sur GitHub →</a:t>
             </a:r>
           </a:p>
         </p:txBody>
@@ -5371,7 +5371,7 @@
                 </a:solidFill>
                 <a:latin typeface="Segoe UI"/>
               </a:rPr>
-              <a:t>HUIT VOIES, CLASSÉES</a:t>
+              <a:t>NEUF VOIES, CLASSÉES</a:t>
             </a:r>
           </a:p>
         </p:txBody>
@@ -5890,7 +5890,7 @@
                 </a:solidFill>
                 <a:latin typeface="Segoe UI"/>
               </a:rPr>
-              <a:t>L'erreur de type d'inscription :</a:t>
+              <a:t>La bifurcation d'inscription :</a:t>
             </a:r>
             <a:r>
               <a:rPr sz="1472" b="0">
@@ -5899,7 +5899,7 @@
                 </a:solidFill>
                 <a:latin typeface="Segoe UI"/>
               </a:rPr>
-              <a:t> un panneau explique « spa » contre « web » et le comportement AADSTS9002327, avec des liens directs vers Q8 et Q7.</a:t>
+              <a:t> un panneau sépare la topologie d'interface de la décision du composant d'échange, avec des liens vers Q8, Q7 et Q15.</a:t>
             </a:r>
           </a:p>
           <a:p>
@@ -6250,7 +6250,7 @@
         </p:nvGraphicFramePr>
         <p:xfrm>
           <a:off x="685800" y="1920240"/>
-          <a:ext cx="10835640" cy="3703320"/>
+          <a:ext cx="10835640" cy="4361688"/>
         </p:xfrm>
         <a:graphic>
           <a:graphicData uri="http://schemas.openxmlformats.org/drawingml/2006/table">
@@ -6264,7 +6264,7 @@
                 <a:gridCol w="1737360"/>
                 <a:gridCol w="3611880"/>
               </a:tblGrid>
-              <a:tr h="617220">
+              <a:tr h="623098">
                 <a:tc>
                   <a:txBody>
                     <a:bodyPr/>
@@ -6354,7 +6354,7 @@
                   </a:tcPr>
                 </a:tc>
               </a:tr>
-              <a:tr h="617220">
+              <a:tr h="623098">
                 <a:tc>
                   <a:txBody>
                     <a:bodyPr/>
@@ -6444,7 +6444,7 @@
                   </a:tcPr>
                 </a:tc>
               </a:tr>
-              <a:tr h="617220">
+              <a:tr h="623098">
                 <a:tc>
                   <a:txBody>
                     <a:bodyPr/>
@@ -6534,7 +6534,7 @@
                   </a:tcPr>
                 </a:tc>
               </a:tr>
-              <a:tr h="617220">
+              <a:tr h="623098">
                 <a:tc>
                   <a:txBody>
                     <a:bodyPr/>
@@ -6624,7 +6624,7 @@
                   </a:tcPr>
                 </a:tc>
               </a:tr>
-              <a:tr h="617220">
+              <a:tr h="623098">
                 <a:tc>
                   <a:txBody>
                     <a:bodyPr/>
@@ -6659,7 +6659,7 @@
                           </a:solidFill>
                           <a:latin typeface="Segoe UI"/>
                         </a:rPr>
-                        <a:t>Confirmer la bibliothèque d'authentification et toute montée de version .NET prévue</a:t>
+                        <a:t>Fournir la preuve de la topologie et de la frontière BFF</a:t>
                       </a:r>
                     </a:p>
                   </a:txBody>
@@ -6703,7 +6703,7 @@
                           </a:solidFill>
                           <a:latin typeface="Segoe UI"/>
                         </a:rPr>
-                        <a:t>Q13</a:t>
+                        <a:t>Q15</a:t>
                       </a:r>
                     </a:p>
                   </a:txBody>
@@ -6714,7 +6714,7 @@
                   </a:tcPr>
                 </a:tc>
               </a:tr>
-              <a:tr h="617220">
+              <a:tr h="623098">
                 <a:tc>
                   <a:txBody>
                     <a:bodyPr/>
@@ -6749,7 +6749,7 @@
                           </a:solidFill>
                           <a:latin typeface="Segoe UI"/>
                         </a:rPr>
-                        <a:t>Évaluer l'acheminement des appels Entra par le VPN site à site existant</a:t>
+                        <a:t>Confirmer la bibliothèque d'authentification et toute montée de version .NET prévue</a:t>
                       </a:r>
                     </a:p>
                   </a:txBody>
@@ -6771,7 +6771,7 @@
                           </a:solidFill>
                           <a:latin typeface="Segoe UI"/>
                         </a:rPr>
-                        <a:t>Conjoint</a:t>
+                        <a:t>Croesus</a:t>
                       </a:r>
                     </a:p>
                   </a:txBody>
@@ -6793,13 +6793,103 @@
                           </a:solidFill>
                           <a:latin typeface="Segoe UI"/>
                         </a:rPr>
+                        <a:t>Q13</a:t>
+                      </a:r>
+                    </a:p>
+                  </a:txBody>
+                  <a:tcPr anchor="ctr">
+                    <a:solidFill>
+                      <a:srgbClr val="FFFFFF"/>
+                    </a:solidFill>
+                  </a:tcPr>
+                </a:tc>
+              </a:tr>
+              <a:tr h="623100">
+                <a:tc>
+                  <a:txBody>
+                    <a:bodyPr/>
+                    <a:lstStyle/>
+                    <a:p>
+                      <a:r>
+                        <a:rPr sz="1196">
+                          <a:solidFill>
+                            <a:srgbClr val="1A1A1A"/>
+                          </a:solidFill>
+                          <a:latin typeface="Segoe UI"/>
+                        </a:rPr>
+                        <a:t>6</a:t>
+                      </a:r>
+                    </a:p>
+                  </a:txBody>
+                  <a:tcPr anchor="ctr">
+                    <a:solidFill>
+                      <a:srgbClr val="F2F6FA"/>
+                    </a:solidFill>
+                  </a:tcPr>
+                </a:tc>
+                <a:tc>
+                  <a:txBody>
+                    <a:bodyPr/>
+                    <a:lstStyle/>
+                    <a:p>
+                      <a:r>
+                        <a:rPr sz="1196">
+                          <a:solidFill>
+                            <a:srgbClr val="1A1A1A"/>
+                          </a:solidFill>
+                          <a:latin typeface="Segoe UI"/>
+                        </a:rPr>
+                        <a:t>Évaluer l'acheminement des appels Entra par le VPN site à site existant</a:t>
+                      </a:r>
+                    </a:p>
+                  </a:txBody>
+                  <a:tcPr anchor="ctr">
+                    <a:solidFill>
+                      <a:srgbClr val="F2F6FA"/>
+                    </a:solidFill>
+                  </a:tcPr>
+                </a:tc>
+                <a:tc>
+                  <a:txBody>
+                    <a:bodyPr/>
+                    <a:lstStyle/>
+                    <a:p>
+                      <a:r>
+                        <a:rPr sz="1196">
+                          <a:solidFill>
+                            <a:srgbClr val="1A1A1A"/>
+                          </a:solidFill>
+                          <a:latin typeface="Segoe UI"/>
+                        </a:rPr>
+                        <a:t>Conjoint</a:t>
+                      </a:r>
+                    </a:p>
+                  </a:txBody>
+                  <a:tcPr anchor="ctr">
+                    <a:solidFill>
+                      <a:srgbClr val="F2F6FA"/>
+                    </a:solidFill>
+                  </a:tcPr>
+                </a:tc>
+                <a:tc>
+                  <a:txBody>
+                    <a:bodyPr/>
+                    <a:lstStyle/>
+                    <a:p>
+                      <a:r>
+                        <a:rPr sz="1196">
+                          <a:solidFill>
+                            <a:srgbClr val="1A1A1A"/>
+                          </a:solidFill>
+                          <a:latin typeface="Segoe UI"/>
+                        </a:rPr>
                         <a:t>Q12 — déblocage le plus rapide</a:t>
                       </a:r>
                     </a:p>
                   </a:txBody>
                   <a:tcPr anchor="ctr">
                     <a:solidFill>
-                      <a:srgbClr val="FFFFFF"/>
+                      <a:srgbClr val="F2F6FA"/>
                     </a:solidFill>
                   </a:tcPr>
                 </a:tc>
@@ -7010,7 +7100,7 @@
                 <a:latin typeface="Segoe UI"/>
                 <a:hlinkClick r:id="rId2"/>
               </a:rPr>
-              <a:t>▶  Constats de la séance et les huit voies — COMMENCER ICI</a:t>
+              <a:t>▶  Constats de la séance et les neuf voies — COMMENCER ICI</a:t>
             </a:r>
           </a:p>
         </p:txBody>
@@ -7042,7 +7132,7 @@
                 <a:latin typeface="Segoe UI"/>
                 <a:hlinkClick r:id="rId3"/>
               </a:rPr>
-              <a:t>▶  Voies et contournements (R1–R8)</a:t>
+              <a:t>▶  Voies et contournements (R1–R9)</a:t>
             </a:r>
           </a:p>
         </p:txBody>
@@ -7074,7 +7164,7 @@
                 <a:latin typeface="Segoe UI"/>
                 <a:hlinkClick r:id="rId4"/>
               </a:rPr>
-              <a:t>▶  Liste des questions Q1–Q14 (dossier d'escalade)</a:t>
+              <a:t>▶  Liste des questions Q1–Q15 (dossier d'escalade)</a:t>
             </a:r>
           </a:p>
         </p:txBody>
@@ -7821,7 +7911,7 @@
                 </a:solidFill>
                 <a:latin typeface="Segoe UI"/>
               </a:rPr>
-              <a:t>Central est une </a:t>
+              <a:t>La topologie d'interface de Central reste </a:t>
             </a:r>
             <a:r>
               <a:rPr sz="1564" b="1">
@@ -7830,7 +7920,7 @@
                 </a:solidFill>
                 <a:latin typeface="Segoe UI"/>
               </a:rPr>
-              <a:t>application multipage rendue côté serveur</a:t>
+              <a:t>non résolue</a:t>
             </a:r>
             <a:r>
               <a:rPr sz="1564" b="0">
@@ -7839,7 +7929,7 @@
                 </a:solidFill>
                 <a:latin typeface="Segoe UI"/>
               </a:rPr>
-              <a:t> — environ 130 pages .aspx sur .NET Framework 4.5.2. Confirmé par le fournisseur. Ce n'est pas une SPA.</a:t>
+              <a:t> : SPA, Web Forms multipage et hybride demeurent possibles. Une URL, les chemins .aspx et PKCE ne la classent pas.</a:t>
             </a:r>
           </a:p>
           <a:p>
@@ -7858,31 +7948,22 @@
               <a:t>▪  </a:t>
             </a:r>
             <a:r>
+              <a:rPr sz="1564" b="1">
+                <a:solidFill>
+                  <a:srgbClr val="1A1A1A"/>
+                </a:solidFill>
+                <a:latin typeface="Segoe UI"/>
+              </a:rPr>
+              <a:t>SPA et BFF sont compatibles. </a:t>
+            </a:r>
+            <a:r>
               <a:rPr sz="1564" b="0">
                 <a:solidFill>
                   <a:srgbClr val="1A1A1A"/>
                 </a:solidFill>
                 <a:latin typeface="Segoe UI"/>
               </a:rPr>
-              <a:t>La plateforme « spa » des trois inscriptions est donc une </a:t>
-            </a:r>
-            <a:r>
-              <a:rPr sz="1564" b="1">
-                <a:solidFill>
-                  <a:srgbClr val="1A1A1A"/>
-                </a:solidFill>
-                <a:latin typeface="Segoe UI"/>
-              </a:rPr>
-              <a:t>erreur de type</a:t>
-            </a:r>
-            <a:r>
-              <a:rPr sz="1564" b="0">
-                <a:solidFill>
-                  <a:srgbClr val="1A1A1A"/>
-                </a:solidFill>
-                <a:latin typeface="Segoe UI"/>
-              </a:rPr>
-              <a:t>, non une description. Central est déjà un Backend-for-Frontend ; c'est la plateforme « web » qui le dit.</a:t>
+              <a:t>Le BFF reste provisoire jusqu'à ce que Q15 confirme la garde des jetons, le témoin de session et la médiation du serveur.</a:t>
             </a:r>
           </a:p>
           <a:p>
@@ -7907,7 +7988,7 @@
                 </a:solidFill>
                 <a:latin typeface="Segoe UI"/>
               </a:rPr>
-              <a:t>Central fonctionne en production : l'échange côté serveur </a:t>
+              <a:t>Le type d'inscription suit le </a:t>
             </a:r>
             <a:r>
               <a:rPr sz="1564" b="1">
@@ -7916,7 +7997,7 @@
                 </a:solidFill>
                 <a:latin typeface="Segoe UI"/>
               </a:rPr>
-              <a:t>réussit</a:t>
+              <a:t>composant qui échange le code</a:t>
             </a:r>
             <a:r>
               <a:rPr sz="1564" b="0">
@@ -7925,16 +8006,7 @@
                 </a:solidFill>
                 <a:latin typeface="Segoe UI"/>
               </a:rPr>
-              <a:t> alors qu'Entra devrait le refuser. Deux explications subsistent — un en-tête Origin synthétisé, ou une inscription « web » non divulguée. </a:t>
-            </a:r>
-            <a:r>
-              <a:rPr sz="1564" b="1">
-                <a:solidFill>
-                  <a:srgbClr val="1A1A1A"/>
-                </a:solidFill>
-                <a:latin typeface="Segoe UI"/>
-              </a:rPr>
-              <a:t>Q8 est la demande prioritaire.</a:t>
+              <a:t>. Si le même serveur échange et conserve les jetons, il est un client confidentiel « web ». Un client public distinct peut légitimement rester « spa ».</a:t>
             </a:r>
           </a:p>
           <a:p>
@@ -9093,7 +9165,7 @@
                 </a:solidFill>
                 <a:latin typeface="Segoe UI"/>
               </a:rPr>
-              <a:t>Conclusion : l'échange se fait côté serveur. Cela corrobore le témoignage d'Olivier et écarte l'échange par navigateur pour cette capture.</a:t>
+              <a:t>Conclusion : /token n'apparaît pas dans cette transaction navigateur. Cela concorde avec le témoignage d'Olivier, sans identifier indépendamment le composant qui l'échange.</a:t>
             </a:r>
           </a:p>
         </p:txBody>
@@ -9128,7 +9200,7 @@
                 </a:solidFill>
                 <a:latin typeface="Segoe UI"/>
               </a:rPr>
-              <a:t>Conséquence : Desjardins ne peut plus observer l'en-tête Origin — il n'existe désormais que sur la requête sortante de Croesus. Réserve : un seul échantillon, un seul environnement.</a:t>
+              <a:t>Conséquence : ce HAR ne classe pas l'interface et ne prouve pas la frontière BFF. Q7, Q8 et Q15 demandent la preuve manquante. Réserve : un seul échantillon, un environnement.</a:t>
             </a:r>
           </a:p>
         </p:txBody>
@@ -9189,7 +9261,7 @@
                 </a:solidFill>
                 <a:latin typeface="Segoe UI"/>
               </a:rPr>
-              <a:t>CE QUI EN DÉCOULE</a:t>
+              <a:t>SI L'ÉCHANGE SERVEUR EST CONFIRMÉ</a:t>
             </a:r>
           </a:p>
         </p:txBody>
@@ -9224,7 +9296,7 @@
                 </a:solidFill>
                 <a:latin typeface="Segoe UI"/>
               </a:rPr>
-              <a:t>L'erreur de type, et les deux explications restantes</a:t>
+              <a:t>Les deux explications restantes</a:t>
             </a:r>
           </a:p>
         </p:txBody>
@@ -9303,7 +9375,7 @@
                 </a:solidFill>
                 <a:latin typeface="Segoe UI"/>
               </a:rPr>
-              <a:t>Entra rejette l'échange côté serveur d'un code d'autorisation « spa » avec l'erreur AADSTS9002327. Or Central fonctionne en production : l'échange réussit. Deux explications subsistent.</a:t>
+              <a:t>Entra rejette l'échange côté serveur d'un code d'autorisation « spa » avec l'erreur AADSTS9002327. Si le même serveur échange et conserve les jetons, le succès en production laisse deux explications.</a:t>
             </a:r>
           </a:p>
         </p:txBody>
@@ -10019,7 +10091,7 @@
                           </a:solidFill>
                           <a:latin typeface="Segoe UI"/>
                         </a:rPr>
-                        <a:t>Une application web rendue côté serveur / BFF</a:t>
+                        <a:t>Un client serveur confidentiel</a:t>
                       </a:r>
                     </a:p>
                   </a:txBody>
@@ -10315,7 +10387,7 @@
                           </a:solidFill>
                           <a:latin typeface="Segoe UI"/>
                         </a:rPr>
-                        <a:t>Ce qu'est réellement Central</a:t>
+                        <a:t>Preuve décisive</a:t>
                       </a:r>
                     </a:p>
                   </a:txBody>
@@ -10337,7 +10409,7 @@
                           </a:solidFill>
                           <a:latin typeface="Segoe UI"/>
                         </a:rPr>
-                        <a:t>Pas ceci</a:t>
+                        <a:t>Le navigateur échange et garde les jetons</a:t>
                       </a:r>
                     </a:p>
                   </a:txBody>
@@ -10359,7 +10431,7 @@
                           </a:solidFill>
                           <a:latin typeface="Segoe UI"/>
                         </a:rPr>
-                        <a:t>Ceci — environ 130 pages .aspx</a:t>
+                        <a:t>Le serveur échange et garde les jetons</a:t>
                       </a:r>
                     </a:p>
                   </a:txBody>
@@ -10500,7 +10572,7 @@
                 </a:solidFill>
                 <a:latin typeface="Segoe UI"/>
               </a:rPr>
-              <a:t>La même erreur de type, en direct dans la démo</a:t>
+              <a:t>La même bifurcation d'architecture, dans la démo</a:t>
             </a:r>
           </a:p>
         </p:txBody>

</xml_diff>